<commit_message>
Fix: 認知バイアスallstaff slide5・緩和ケアallstaff slide5 gap拡大
Co-Authored-By: Claude Opus 4.6 <noreply@anthropic.com>
</commit_message>
<xml_diff>
--- a/output/education/2026-03-30_cognitive-bias-diagnostic-reasoning/cognitive-bias-diagnostic-reasoning_slides_allstaff.pptx
+++ b/output/education/2026-03-30_cognitive-bias-diagnostic-reasoning/cognitive-bias-diagnostic-reasoning_slides_allstaff.pptx
@@ -6115,7 +6115,7 @@
         </p:nvGraphicFramePr>
         <p:xfrm>
           <a:off x="274320" y="1005840"/>
-          <a:ext cx="8595360" cy="2743200"/>
+          <a:ext cx="8595360" cy="2468880"/>
         </p:xfrm>
         <a:graphic>
           <a:graphicData uri="http://schemas.openxmlformats.org/drawingml/2006/table">
@@ -6562,8 +6562,8 @@
         </p:nvSpPr>
         <p:spPr>
           <a:xfrm>
-            <a:off x="457200" y="3840480"/>
-            <a:ext cx="8229600" cy="731520"/>
+            <a:off x="457200" y="3657600"/>
+            <a:ext cx="8229600" cy="640080"/>
           </a:xfrm>
           <a:prstGeom prst="rect">
             <a:avLst/>
@@ -6605,8 +6605,8 @@
         </p:nvSpPr>
         <p:spPr>
           <a:xfrm>
-            <a:off x="640080" y="3886200"/>
-            <a:ext cx="7772400" cy="640080"/>
+            <a:off x="640080" y="3703320"/>
+            <a:ext cx="7772400" cy="548640"/>
           </a:xfrm>
           <a:prstGeom prst="rect">
             <a:avLst/>

</xml_diff>